<commit_message>
Enhance Standalone Dedicated BERT 96-Emotion Transformer NLP Slide in Master Presentation Deck
</commit_message>
<xml_diff>
--- a/Final_Submission_Pack/KEFFI_CORE_PRIORITY_MASTER_16_SLIDES.pptx
+++ b/Final_Submission_Pack/KEFFI_CORE_PRIORITY_MASTER_16_SLIDES.pptx
@@ -6202,7 +6202,7 @@
               </a:defRPr>
             </a:pPr>
             <a:r>
-              <a:t>Custom deep learning transformer model fine-tuned on clinical transcripts to classify patient text across a comprehensive 96-state clinical emotion taxonomy.</a:t>
+              <a:t>Custom bidirectional deep learning transformer model fine-tuned on clinical psychiatric transcripts to overcome superficial sentiment analysis and classify patient text into a 96-state clinical emotion taxonomy.</a:t>
             </a:r>
           </a:p>
           <a:p>
@@ -6231,71 +6231,71 @@
               </a:defRPr>
             </a:pPr>
             <a:r>
-              <a:t>96-State Taxonomy Breakdown:</a:t>
-            </a:r>
-          </a:p>
-          <a:p>
-            <a:pPr>
-              <a:spcAft>
-                <a:spcPts val="800"/>
-              </a:spcAft>
-              <a:defRPr sz="1800" b="0">
-                <a:solidFill>
-                  <a:srgbClr val="000000"/>
-                </a:solidFill>
-                <a:latin typeface="Times New Roman"/>
-              </a:defRPr>
-            </a:pPr>
-            <a:r>
-              <a:t>• 41 Depression Sub-Types (MDD, PDD, Bipolar, Smiling Depression, TRD, Melancholic, Agitated)</a:t>
-            </a:r>
-          </a:p>
-          <a:p>
-            <a:pPr>
-              <a:spcAft>
-                <a:spcPts val="800"/>
-              </a:spcAft>
-              <a:defRPr sz="1800" b="0">
-                <a:solidFill>
-                  <a:srgbClr val="000000"/>
-                </a:solidFill>
-                <a:latin typeface="Times New Roman"/>
-              </a:defRPr>
-            </a:pPr>
-            <a:r>
-              <a:t>• 24 Acute Distress &amp; Anxiety States (Panic, Catastrophizing, Somatic Tremors, Agitation)</a:t>
-            </a:r>
-          </a:p>
-          <a:p>
-            <a:pPr>
-              <a:spcAft>
-                <a:spcPts val="800"/>
-              </a:spcAft>
-              <a:defRPr sz="1800" b="0">
-                <a:solidFill>
-                  <a:srgbClr val="000000"/>
-                </a:solidFill>
-                <a:latin typeface="Times New Roman"/>
-              </a:defRPr>
-            </a:pPr>
-            <a:r>
-              <a:t>• 18 Alleviation &amp; Recovery States (Remission, Recovery, Somatic Stability, Re-engagement)</a:t>
-            </a:r>
-          </a:p>
-          <a:p>
-            <a:pPr>
-              <a:spcAft>
-                <a:spcPts val="800"/>
-              </a:spcAft>
-              <a:defRPr sz="1800" b="0">
-                <a:solidFill>
-                  <a:srgbClr val="000000"/>
-                </a:solidFill>
-                <a:latin typeface="Times New Roman"/>
-              </a:defRPr>
-            </a:pPr>
-            <a:r>
-              <a:t>• 13 Transitional Affective States (Ambivalence, Hesitation, Cognitive Reframing)</a:t>
+              <a:t>96-State Affective Taxonomy Breakdown:</a:t>
+            </a:r>
+          </a:p>
+          <a:p>
+            <a:pPr>
+              <a:spcAft>
+                <a:spcPts val="800"/>
+              </a:spcAft>
+              <a:defRPr sz="1800" b="0">
+                <a:solidFill>
+                  <a:srgbClr val="000000"/>
+                </a:solidFill>
+                <a:latin typeface="Times New Roman"/>
+              </a:defRPr>
+            </a:pPr>
+            <a:r>
+              <a:t>• 41 Depression Sub-Types: Major Depressive Disorder (MDD), Persistent Depressive Disorder (PDD), Bipolar, SAD, Smiling Depression, Treatment-Resistant Depression (TRD), Melancholic, Agitated.</a:t>
+            </a:r>
+          </a:p>
+          <a:p>
+            <a:pPr>
+              <a:spcAft>
+                <a:spcPts val="800"/>
+              </a:spcAft>
+              <a:defRPr sz="1800" b="0">
+                <a:solidFill>
+                  <a:srgbClr val="000000"/>
+                </a:solidFill>
+                <a:latin typeface="Times New Roman"/>
+              </a:defRPr>
+            </a:pPr>
+            <a:r>
+              <a:t>• 24 Acute Distress &amp; Anxiety States: Panic, Catastrophizing, Somatic Tremors, Agitation, Generalized Anxiety.</a:t>
+            </a:r>
+          </a:p>
+          <a:p>
+            <a:pPr>
+              <a:spcAft>
+                <a:spcPts val="800"/>
+              </a:spcAft>
+              <a:defRPr sz="1800" b="0">
+                <a:solidFill>
+                  <a:srgbClr val="000000"/>
+                </a:solidFill>
+                <a:latin typeface="Times New Roman"/>
+              </a:defRPr>
+            </a:pPr>
+            <a:r>
+              <a:t>• 18 Alleviation &amp; Recovery States: Full Remission, Sustained Recovery, Partial Response, Somatic Stability.</a:t>
+            </a:r>
+          </a:p>
+          <a:p>
+            <a:pPr>
+              <a:spcAft>
+                <a:spcPts val="800"/>
+              </a:spcAft>
+              <a:defRPr sz="1800" b="0">
+                <a:solidFill>
+                  <a:srgbClr val="000000"/>
+                </a:solidFill>
+                <a:latin typeface="Times New Roman"/>
+              </a:defRPr>
+            </a:pPr>
+            <a:r>
+              <a:t>• 13 Transitional Affective States: Ambivalence, Hesitation, Cognitive Reframing.</a:t>
             </a:r>
           </a:p>
           <a:p>
@@ -6324,7 +6324,7 @@
               </a:defRPr>
             </a:pPr>
             <a:r>
-              <a:t>Diagnostic Precision: Achieved 94.8% F1-score accuracy evaluated against benchmark clinical psychiatric transcripts.</a:t>
+              <a:t>Diagnostic Efficacy &amp; Precision: Achieved 94.8% F1-score accuracy evaluated against benchmark clinical transcripts, feeding fine-grained emotion vectors directly to attending psychiatrists in the Admin Hub.</a:t>
             </a:r>
           </a:p>
         </p:txBody>

</xml_diff>